<commit_message>
Update challenge shortlinks to tinyurl.com/baysec-week4 and baysec-week5, add 404 smart routing
</commit_message>
<xml_diff>
--- a/week5/BaySec_Week5_Foundations.pptx
+++ b/week5/BaySec_Week5_Foundations.pptx
@@ -7167,7 +7167,7 @@
               </a:defRPr>
             </a:pPr>
             <a:r>
-              <a:t>TARGET PORTAL: https://MynameisKoi.github.io/baysec/week5/</a:t>
+              <a:t>TARGET PORTAL: tinyurl.com/baysec-week5</a:t>
             </a:r>
           </a:p>
         </p:txBody>
@@ -7353,7 +7353,7 @@
               </a:defRPr>
             </a:pPr>
             <a:r>
-              <a:t>or visit baysec/week5</a:t>
+              <a:t>or visit tinyurl.com/baysec-week5</a:t>
             </a:r>
           </a:p>
         </p:txBody>

</xml_diff>